<commit_message>
swapping order of nematode and arthropod lab
</commit_message>
<xml_diff>
--- a/docs/lectures/in-class_activities/class_13.pptx
+++ b/docs/lectures/in-class_activities/class_13.pptx
@@ -766,16 +766,32 @@
           <a:lstStyle/>
           <a:p>
             <a:r>
-              <a:rPr lang="en-US"/>
+              <a:rPr lang="en-US" dirty="0"/>
               <a:t>Do not modify the notes in this section to avoid tampering with the Poll Everywhere activity.
-More info at polleverywhere.com/support
+More info at </a:t>
+            </a:r>
+            <a:r>
+              <a:rPr lang="en-US" dirty="0" err="1"/>
+              <a:t>polleverywhere.com</a:t>
+            </a:r>
+            <a:r>
+              <a:rPr lang="en-US" dirty="0"/>
+              <a:t>/support
 Can you think of a situation where conserving biodiversity leads to reductions in the transmission of a parasite?</a:t>
             </a:r>
           </a:p>
           <a:p>
             <a:r>
-              <a:rPr lang="en-US"/>
-              <a:t>https://www.polleverywhere.com/discourses/v8gpj6SsDMacqfeLvR63Y</a:t>
+              <a:rPr lang="en-US" dirty="0"/>
+              <a:t>https://</a:t>
+            </a:r>
+            <a:r>
+              <a:rPr lang="en-US" dirty="0" err="1"/>
+              <a:t>www.polleverywhere.com</a:t>
+            </a:r>
+            <a:r>
+              <a:rPr lang="en-US" dirty="0"/>
+              <a:t>/discourses/v8gpj6SsDMacqfeLvR63Y</a:t>
             </a:r>
           </a:p>
         </p:txBody>
@@ -5245,35 +5261,7 @@
                 <a:latin typeface="Avenir"/>
                 <a:cs typeface="Avenir"/>
               </a:rPr>
-              <a:t>Write on your </a:t>
-            </a:r>
-            <a:r>
-              <a:rPr lang="en-US" sz="2600" b="1">
-                <a:latin typeface="Avenir"/>
-                <a:cs typeface="Avenir"/>
-              </a:rPr>
-              <a:t>own (2 </a:t>
-            </a:r>
-            <a:r>
-              <a:rPr lang="en-US" sz="2600" b="1" dirty="0">
-                <a:latin typeface="Avenir"/>
-                <a:cs typeface="Avenir"/>
-              </a:rPr>
-              <a:t>m), hone a final answer with your </a:t>
-            </a:r>
-            <a:r>
-              <a:rPr lang="en-US" sz="2600" b="1">
-                <a:latin typeface="Avenir"/>
-                <a:cs typeface="Avenir"/>
-              </a:rPr>
-              <a:t>group (4 </a:t>
-            </a:r>
-            <a:r>
-              <a:rPr lang="en-US" sz="2600" b="1" dirty="0">
-                <a:latin typeface="Avenir"/>
-                <a:cs typeface="Avenir"/>
-              </a:rPr>
-              <a:t>m), then share with the class (5 m).</a:t>
+              <a:t>Write on your own (2 m), hone a final answer with your group (4 m), then share with the class (5 m).</a:t>
             </a:r>
           </a:p>
         </p:txBody>

</xml_diff>